<commit_message>
Publish-ready: keep only run-essential files; stop tracking tests, demo, and internal docs
</commit_message>
<xml_diff>
--- a/Screen Capture Tool/deliverables/Code_Capture_Demo.pptx
+++ b/Screen Capture Tool/deliverables/Code_Capture_Demo.pptx
@@ -11,9 +11,9 @@
     <p:sldId id="256" r:id="rId2"/>
     <p:sldId id="257" r:id="rId3"/>
     <p:sldId id="258" r:id="rId4"/>
-    <p:sldId id="259" r:id="rId5"/>
-    <p:sldId id="260" r:id="rId6"/>
-    <p:sldId id="261" r:id="rId7"/>
+    <p:sldId id="260" r:id="rId5"/>
+    <p:sldId id="261" r:id="rId6"/>
+    <p:sldId id="259" r:id="rId7"/>
     <p:sldId id="262" r:id="rId8"/>
   </p:sldIdLst>
   <p:sldSz cx="12192000" cy="6858000"/>
@@ -2724,406 +2724,6 @@
 
 <file path=ppt/slides/slide4.xml><?xml version="1.0" encoding="utf-8"?>
 <p:sld xmlns:a="http://schemas.openxmlformats.org/drawingml/2006/main" xmlns:r="http://schemas.openxmlformats.org/officeDocument/2006/relationships" xmlns:p="http://schemas.openxmlformats.org/presentationml/2006/main">
-  <p:cSld name="Slide 4">
-    <p:bg>
-      <p:bgPr>
-        <a:solidFill>
-          <a:srgbClr val="2B2622"/>
-        </a:solidFill>
-        <a:effectLst/>
-      </p:bgPr>
-    </p:bg>
-    <p:spTree>
-      <p:nvGrpSpPr>
-        <p:cNvPr id="1" name=""/>
-        <p:cNvGrpSpPr/>
-        <p:nvPr/>
-      </p:nvGrpSpPr>
-      <p:grpSpPr>
-        <a:xfrm>
-          <a:off x="0" y="0"/>
-          <a:ext cx="0" cy="0"/>
-          <a:chOff x="0" y="0"/>
-          <a:chExt cx="0" cy="0"/>
-        </a:xfrm>
-      </p:grpSpPr>
-      <p:sp>
-        <p:nvSpPr>
-          <p:cNvPr id="2" name="Shape 0"/>
-          <p:cNvSpPr/>
-          <p:nvPr/>
-        </p:nvSpPr>
-        <p:spPr>
-          <a:xfrm>
-            <a:off x="822960" y="777240"/>
-            <a:ext cx="822960" cy="822960"/>
-          </a:xfrm>
-          <a:prstGeom prst="ellipse">
-            <a:avLst/>
-          </a:prstGeom>
-          <a:solidFill>
-            <a:srgbClr val="BE6E4A"/>
-          </a:solidFill>
-          <a:ln/>
-        </p:spPr>
-        <p:txBody>
-          <a:bodyPr/>
-          <a:lstStyle/>
-          <a:p>
-            <a:endParaRPr lang="en-US"/>
-          </a:p>
-        </p:txBody>
-      </p:sp>
-      <p:sp>
-        <p:nvSpPr>
-          <p:cNvPr id="3" name="Text 1"/>
-          <p:cNvSpPr/>
-          <p:nvPr/>
-        </p:nvSpPr>
-        <p:spPr>
-          <a:xfrm>
-            <a:off x="822960" y="777240"/>
-            <a:ext cx="822960" cy="822960"/>
-          </a:xfrm>
-          <a:prstGeom prst="rect">
-            <a:avLst/>
-          </a:prstGeom>
-          <a:noFill/>
-          <a:ln/>
-        </p:spPr>
-        <p:txBody>
-          <a:bodyPr wrap="square" lIns="0" tIns="0" rIns="0" bIns="0" rtlCol="0" anchor="ctr"/>
-          <a:lstStyle/>
-          <a:p>
-            <a:pPr marL="0" indent="0" algn="ctr">
-              <a:buNone/>
-            </a:pPr>
-            <a:r>
-              <a:rPr lang="en-US" sz="3000" dirty="0">
-                <a:solidFill>
-                  <a:srgbClr val="FFFFFF"/>
-                </a:solidFill>
-              </a:rPr>
-              <a:t>▶</a:t>
-            </a:r>
-            <a:endParaRPr lang="en-US" sz="3000" dirty="0"/>
-          </a:p>
-        </p:txBody>
-      </p:sp>
-      <p:sp>
-        <p:nvSpPr>
-          <p:cNvPr id="4" name="Text 2"/>
-          <p:cNvSpPr/>
-          <p:nvPr/>
-        </p:nvSpPr>
-        <p:spPr>
-          <a:xfrm>
-            <a:off x="1828800" y="822960"/>
-            <a:ext cx="7315200" cy="822960"/>
-          </a:xfrm>
-          <a:prstGeom prst="rect">
-            <a:avLst/>
-          </a:prstGeom>
-          <a:noFill/>
-          <a:ln/>
-        </p:spPr>
-        <p:txBody>
-          <a:bodyPr wrap="square" lIns="0" tIns="0" rIns="0" bIns="0" rtlCol="0" anchor="ctr"/>
-          <a:lstStyle/>
-          <a:p>
-            <a:pPr marL="0" indent="0">
-              <a:buNone/>
-            </a:pPr>
-            <a:r>
-              <a:rPr lang="en-US" sz="4000" b="1" dirty="0">
-                <a:solidFill>
-                  <a:srgbClr val="FFFFFF"/>
-                </a:solidFill>
-                <a:latin typeface="Cambria" pitchFamily="34" charset="0"/>
-                <a:ea typeface="Cambria" pitchFamily="34" charset="-122"/>
-                <a:cs typeface="Cambria" pitchFamily="34" charset="-120"/>
-              </a:rPr>
-              <a:t>Live Demo</a:t>
-            </a:r>
-            <a:endParaRPr lang="en-US" sz="4000" dirty="0"/>
-          </a:p>
-        </p:txBody>
-      </p:sp>
-      <p:sp>
-        <p:nvSpPr>
-          <p:cNvPr id="5" name="Text 3"/>
-          <p:cNvSpPr/>
-          <p:nvPr/>
-        </p:nvSpPr>
-        <p:spPr>
-          <a:xfrm>
-            <a:off x="914400" y="1920240"/>
-            <a:ext cx="5852160" cy="2926080"/>
-          </a:xfrm>
-          <a:prstGeom prst="rect">
-            <a:avLst/>
-          </a:prstGeom>
-          <a:noFill/>
-          <a:ln/>
-        </p:spPr>
-        <p:txBody>
-          <a:bodyPr wrap="square" lIns="0" tIns="0" rIns="0" bIns="0" rtlCol="0" anchor="ctr"/>
-          <a:lstStyle/>
-          <a:p>
-            <a:pPr marL="342900" indent="-342900">
-              <a:spcAft>
-                <a:spcPts val="1200"/>
-              </a:spcAft>
-              <a:buSzPct val="100000"/>
-              <a:buChar char="•"/>
-            </a:pPr>
-            <a:r>
-              <a:rPr lang="en-US" sz="1700" dirty="0">
-                <a:solidFill>
-                  <a:srgbClr val="E9E2DC"/>
-                </a:solidFill>
-                <a:latin typeface="Calibri" pitchFamily="34" charset="0"/>
-                <a:ea typeface="Calibri" pitchFamily="34" charset="-122"/>
-                <a:cs typeface="Calibri" pitchFamily="34" charset="-120"/>
-              </a:rPr>
-              <a:t>Start capture</a:t>
-            </a:r>
-            <a:endParaRPr lang="en-US" sz="1700" dirty="0"/>
-          </a:p>
-          <a:p>
-            <a:pPr marL="342900" indent="-342900">
-              <a:spcAft>
-                <a:spcPts val="1200"/>
-              </a:spcAft>
-              <a:buSzPct val="100000"/>
-              <a:buChar char="•"/>
-            </a:pPr>
-            <a:r>
-              <a:rPr lang="en-US" sz="1700" dirty="0">
-                <a:solidFill>
-                  <a:srgbClr val="E9E2DC"/>
-                </a:solidFill>
-                <a:latin typeface="Calibri" pitchFamily="34" charset="0"/>
-                <a:ea typeface="Calibri" pitchFamily="34" charset="-122"/>
-                <a:cs typeface="Calibri" pitchFamily="34" charset="-120"/>
-              </a:rPr>
-              <a:t>Switch to the editor  →  press  Cmd+Shift+1</a:t>
-            </a:r>
-            <a:endParaRPr lang="en-US" sz="1700" dirty="0"/>
-          </a:p>
-          <a:p>
-            <a:pPr marL="342900" indent="-342900">
-              <a:spcAft>
-                <a:spcPts val="1200"/>
-              </a:spcAft>
-              <a:buSzPct val="100000"/>
-              <a:buChar char="•"/>
-            </a:pPr>
-            <a:r>
-              <a:rPr lang="en-US" sz="1700" dirty="0">
-                <a:solidFill>
-                  <a:srgbClr val="E9E2DC"/>
-                </a:solidFill>
-                <a:latin typeface="Calibri" pitchFamily="34" charset="0"/>
-                <a:ea typeface="Calibri" pitchFamily="34" charset="-122"/>
-                <a:cs typeface="Calibri" pitchFamily="34" charset="-120"/>
-              </a:rPr>
-              <a:t>Scroll slowly (or not at all for a one-screen file)</a:t>
-            </a:r>
-            <a:endParaRPr lang="en-US" sz="1700" dirty="0"/>
-          </a:p>
-          <a:p>
-            <a:pPr marL="342900" indent="-342900">
-              <a:spcAft>
-                <a:spcPts val="1200"/>
-              </a:spcAft>
-              <a:buSzPct val="100000"/>
-              <a:buChar char="•"/>
-            </a:pPr>
-            <a:r>
-              <a:rPr lang="en-US" sz="1700" dirty="0">
-                <a:solidFill>
-                  <a:srgbClr val="E9E2DC"/>
-                </a:solidFill>
-                <a:latin typeface="Calibri" pitchFamily="34" charset="0"/>
-                <a:ea typeface="Calibri" pitchFamily="34" charset="-122"/>
-                <a:cs typeface="Calibri" pitchFamily="34" charset="-120"/>
-              </a:rPr>
-              <a:t>Walk the report: overview · errors · code · tech review · diagrams</a:t>
-            </a:r>
-            <a:endParaRPr lang="en-US" sz="1700" dirty="0"/>
-          </a:p>
-        </p:txBody>
-      </p:sp>
-      <p:sp>
-        <p:nvSpPr>
-          <p:cNvPr id="6" name="Shape 4"/>
-          <p:cNvSpPr/>
-          <p:nvPr/>
-        </p:nvSpPr>
-        <p:spPr>
-          <a:xfrm>
-            <a:off x="7040880" y="1828800"/>
-            <a:ext cx="4572000" cy="3566160"/>
-          </a:xfrm>
-          <a:prstGeom prst="roundRect">
-            <a:avLst>
-              <a:gd name="adj" fmla="val 2564"/>
-            </a:avLst>
-          </a:prstGeom>
-          <a:solidFill>
-            <a:srgbClr val="3A322C"/>
-          </a:solidFill>
-          <a:ln w="12700">
-            <a:solidFill>
-              <a:srgbClr val="BE6E4A"/>
-            </a:solidFill>
-            <a:prstDash val="dash"/>
-          </a:ln>
-        </p:spPr>
-        <p:txBody>
-          <a:bodyPr/>
-          <a:lstStyle/>
-          <a:p>
-            <a:endParaRPr lang="en-US"/>
-          </a:p>
-        </p:txBody>
-      </p:sp>
-      <p:sp>
-        <p:nvSpPr>
-          <p:cNvPr id="7" name="Text 5"/>
-          <p:cNvSpPr/>
-          <p:nvPr/>
-        </p:nvSpPr>
-        <p:spPr>
-          <a:xfrm>
-            <a:off x="7223760" y="3017520"/>
-            <a:ext cx="4206240" cy="1097280"/>
-          </a:xfrm>
-          <a:prstGeom prst="rect">
-            <a:avLst/>
-          </a:prstGeom>
-          <a:noFill/>
-          <a:ln/>
-        </p:spPr>
-        <p:txBody>
-          <a:bodyPr wrap="square" lIns="0" tIns="0" rIns="0" bIns="0" rtlCol="0" anchor="ctr"/>
-          <a:lstStyle/>
-          <a:p>
-            <a:pPr marL="0" indent="0" algn="ctr">
-              <a:buNone/>
-            </a:pPr>
-            <a:r>
-              <a:rPr lang="en-US" sz="1400" i="1" dirty="0">
-                <a:solidFill>
-                  <a:srgbClr val="B9AEA4"/>
-                </a:solidFill>
-                <a:latin typeface="Calibri" pitchFamily="34" charset="0"/>
-                <a:ea typeface="Calibri" pitchFamily="34" charset="-122"/>
-                <a:cs typeface="Calibri" pitchFamily="34" charset="-120"/>
-              </a:rPr>
-              <a:t>Backup slot</a:t>
-            </a:r>
-            <a:endParaRPr lang="en-US" sz="1400" dirty="0"/>
-          </a:p>
-          <a:p>
-            <a:pPr marL="0" indent="0" algn="ctr">
-              <a:buNone/>
-            </a:pPr>
-            <a:r>
-              <a:rPr lang="en-US" sz="1400" i="1" dirty="0">
-                <a:solidFill>
-                  <a:srgbClr val="B9AEA4"/>
-                </a:solidFill>
-                <a:latin typeface="Calibri" pitchFamily="34" charset="0"/>
-                <a:ea typeface="Calibri" pitchFamily="34" charset="-122"/>
-                <a:cs typeface="Calibri" pitchFamily="34" charset="-120"/>
-              </a:rPr>
-              <a:t>(paste a rehearsal report screenshot here)</a:t>
-            </a:r>
-            <a:endParaRPr lang="en-US" sz="1400" dirty="0"/>
-          </a:p>
-        </p:txBody>
-      </p:sp>
-      <p:sp>
-        <p:nvSpPr>
-          <p:cNvPr id="8" name="Text 6"/>
-          <p:cNvSpPr/>
-          <p:nvPr/>
-        </p:nvSpPr>
-        <p:spPr>
-          <a:xfrm>
-            <a:off x="914400" y="5852160"/>
-            <a:ext cx="10332720" cy="365760"/>
-          </a:xfrm>
-          <a:prstGeom prst="rect">
-            <a:avLst/>
-          </a:prstGeom>
-          <a:noFill/>
-          <a:ln/>
-        </p:spPr>
-        <p:txBody>
-          <a:bodyPr wrap="square" lIns="0" tIns="0" rIns="0" bIns="0" rtlCol="0" anchor="ctr"/>
-          <a:lstStyle/>
-          <a:p>
-            <a:pPr marL="0" indent="0">
-              <a:buNone/>
-            </a:pPr>
-            <a:r>
-              <a:rPr lang="en-US" sz="1300" i="1" dirty="0">
-                <a:solidFill>
-                  <a:srgbClr val="B9AEA4"/>
-                </a:solidFill>
-                <a:latin typeface="Calibri" pitchFamily="34" charset="0"/>
-                <a:ea typeface="Calibri" pitchFamily="34" charset="-122"/>
-                <a:cs typeface="Calibri" pitchFamily="34" charset="-120"/>
-              </a:rPr>
-              <a:t>Line numbers OFF · file fits the screen · keep this backup ready</a:t>
-            </a:r>
-            <a:endParaRPr lang="en-US" sz="1300" dirty="0"/>
-          </a:p>
-        </p:txBody>
-      </p:sp>
-      <p:pic>
-        <p:nvPicPr>
-          <p:cNvPr id="9" name="Picture 8">
-            <a:extLst>
-              <a:ext uri="{FF2B5EF4-FFF2-40B4-BE49-F238E27FC236}">
-                <a16:creationId xmlns:a16="http://schemas.microsoft.com/office/drawing/2014/main" id="{48D8A69B-695C-54D2-E0EC-5672EE906C09}"/>
-              </a:ext>
-            </a:extLst>
-          </p:cNvPr>
-          <p:cNvPicPr>
-            <a:picLocks noChangeAspect="1"/>
-          </p:cNvPicPr>
-          <p:nvPr/>
-        </p:nvPicPr>
-        <p:blipFill>
-          <a:blip r:embed="rId3"/>
-          <a:stretch>
-            <a:fillRect/>
-          </a:stretch>
-        </p:blipFill>
-        <p:spPr>
-          <a:xfrm>
-            <a:off x="6244284" y="982980"/>
-            <a:ext cx="5799432" cy="5257800"/>
-          </a:xfrm>
-          <a:prstGeom prst="rect">
-            <a:avLst/>
-          </a:prstGeom>
-        </p:spPr>
-      </p:pic>
-    </p:spTree>
-  </p:cSld>
-  <p:clrMapOvr>
-    <a:masterClrMapping/>
-  </p:clrMapOvr>
-</p:sld>
-</file>
-
-<file path=ppt/slides/slide5.xml><?xml version="1.0" encoding="utf-8"?>
-<p:sld xmlns:a="http://schemas.openxmlformats.org/drawingml/2006/main" xmlns:r="http://schemas.openxmlformats.org/officeDocument/2006/relationships" xmlns:p="http://schemas.openxmlformats.org/presentationml/2006/main">
   <p:cSld name="Slide 5">
     <p:bg>
       <p:bgPr>
@@ -3467,7 +3067,7 @@
 </p:sld>
 </file>
 
-<file path=ppt/slides/slide6.xml><?xml version="1.0" encoding="utf-8"?>
+<file path=ppt/slides/slide5.xml><?xml version="1.0" encoding="utf-8"?>
 <p:sld xmlns:a="http://schemas.openxmlformats.org/drawingml/2006/main" xmlns:r="http://schemas.openxmlformats.org/officeDocument/2006/relationships" xmlns:p="http://schemas.openxmlformats.org/presentationml/2006/main">
   <p:cSld name="Slide 6">
     <p:bg>
@@ -3849,6 +3449,406 @@
           <a:xfrm>
             <a:off x="5843295" y="1463040"/>
             <a:ext cx="6144210" cy="4855160"/>
+          </a:xfrm>
+          <a:prstGeom prst="rect">
+            <a:avLst/>
+          </a:prstGeom>
+        </p:spPr>
+      </p:pic>
+    </p:spTree>
+  </p:cSld>
+  <p:clrMapOvr>
+    <a:masterClrMapping/>
+  </p:clrMapOvr>
+</p:sld>
+</file>
+
+<file path=ppt/slides/slide6.xml><?xml version="1.0" encoding="utf-8"?>
+<p:sld xmlns:a="http://schemas.openxmlformats.org/drawingml/2006/main" xmlns:r="http://schemas.openxmlformats.org/officeDocument/2006/relationships" xmlns:p="http://schemas.openxmlformats.org/presentationml/2006/main">
+  <p:cSld name="Slide 4">
+    <p:bg>
+      <p:bgPr>
+        <a:solidFill>
+          <a:srgbClr val="2B2622"/>
+        </a:solidFill>
+        <a:effectLst/>
+      </p:bgPr>
+    </p:bg>
+    <p:spTree>
+      <p:nvGrpSpPr>
+        <p:cNvPr id="1" name=""/>
+        <p:cNvGrpSpPr/>
+        <p:nvPr/>
+      </p:nvGrpSpPr>
+      <p:grpSpPr>
+        <a:xfrm>
+          <a:off x="0" y="0"/>
+          <a:ext cx="0" cy="0"/>
+          <a:chOff x="0" y="0"/>
+          <a:chExt cx="0" cy="0"/>
+        </a:xfrm>
+      </p:grpSpPr>
+      <p:sp>
+        <p:nvSpPr>
+          <p:cNvPr id="2" name="Shape 0"/>
+          <p:cNvSpPr/>
+          <p:nvPr/>
+        </p:nvSpPr>
+        <p:spPr>
+          <a:xfrm>
+            <a:off x="822960" y="777240"/>
+            <a:ext cx="822960" cy="822960"/>
+          </a:xfrm>
+          <a:prstGeom prst="ellipse">
+            <a:avLst/>
+          </a:prstGeom>
+          <a:solidFill>
+            <a:srgbClr val="BE6E4A"/>
+          </a:solidFill>
+          <a:ln/>
+        </p:spPr>
+        <p:txBody>
+          <a:bodyPr/>
+          <a:lstStyle/>
+          <a:p>
+            <a:endParaRPr lang="en-US"/>
+          </a:p>
+        </p:txBody>
+      </p:sp>
+      <p:sp>
+        <p:nvSpPr>
+          <p:cNvPr id="3" name="Text 1"/>
+          <p:cNvSpPr/>
+          <p:nvPr/>
+        </p:nvSpPr>
+        <p:spPr>
+          <a:xfrm>
+            <a:off x="822960" y="777240"/>
+            <a:ext cx="822960" cy="822960"/>
+          </a:xfrm>
+          <a:prstGeom prst="rect">
+            <a:avLst/>
+          </a:prstGeom>
+          <a:noFill/>
+          <a:ln/>
+        </p:spPr>
+        <p:txBody>
+          <a:bodyPr wrap="square" lIns="0" tIns="0" rIns="0" bIns="0" rtlCol="0" anchor="ctr"/>
+          <a:lstStyle/>
+          <a:p>
+            <a:pPr marL="0" indent="0" algn="ctr">
+              <a:buNone/>
+            </a:pPr>
+            <a:r>
+              <a:rPr lang="en-US" sz="3000" dirty="0">
+                <a:solidFill>
+                  <a:srgbClr val="FFFFFF"/>
+                </a:solidFill>
+              </a:rPr>
+              <a:t>▶</a:t>
+            </a:r>
+            <a:endParaRPr lang="en-US" sz="3000" dirty="0"/>
+          </a:p>
+        </p:txBody>
+      </p:sp>
+      <p:sp>
+        <p:nvSpPr>
+          <p:cNvPr id="4" name="Text 2"/>
+          <p:cNvSpPr/>
+          <p:nvPr/>
+        </p:nvSpPr>
+        <p:spPr>
+          <a:xfrm>
+            <a:off x="1828800" y="822960"/>
+            <a:ext cx="7315200" cy="822960"/>
+          </a:xfrm>
+          <a:prstGeom prst="rect">
+            <a:avLst/>
+          </a:prstGeom>
+          <a:noFill/>
+          <a:ln/>
+        </p:spPr>
+        <p:txBody>
+          <a:bodyPr wrap="square" lIns="0" tIns="0" rIns="0" bIns="0" rtlCol="0" anchor="ctr"/>
+          <a:lstStyle/>
+          <a:p>
+            <a:pPr marL="0" indent="0">
+              <a:buNone/>
+            </a:pPr>
+            <a:r>
+              <a:rPr lang="en-US" sz="4000" b="1" dirty="0">
+                <a:solidFill>
+                  <a:srgbClr val="FFFFFF"/>
+                </a:solidFill>
+                <a:latin typeface="Cambria" pitchFamily="34" charset="0"/>
+                <a:ea typeface="Cambria" pitchFamily="34" charset="-122"/>
+                <a:cs typeface="Cambria" pitchFamily="34" charset="-120"/>
+              </a:rPr>
+              <a:t>Live Demo</a:t>
+            </a:r>
+            <a:endParaRPr lang="en-US" sz="4000" dirty="0"/>
+          </a:p>
+        </p:txBody>
+      </p:sp>
+      <p:sp>
+        <p:nvSpPr>
+          <p:cNvPr id="5" name="Text 3"/>
+          <p:cNvSpPr/>
+          <p:nvPr/>
+        </p:nvSpPr>
+        <p:spPr>
+          <a:xfrm>
+            <a:off x="914400" y="1920240"/>
+            <a:ext cx="5852160" cy="2926080"/>
+          </a:xfrm>
+          <a:prstGeom prst="rect">
+            <a:avLst/>
+          </a:prstGeom>
+          <a:noFill/>
+          <a:ln/>
+        </p:spPr>
+        <p:txBody>
+          <a:bodyPr wrap="square" lIns="0" tIns="0" rIns="0" bIns="0" rtlCol="0" anchor="ctr"/>
+          <a:lstStyle/>
+          <a:p>
+            <a:pPr marL="342900" indent="-342900">
+              <a:spcAft>
+                <a:spcPts val="1200"/>
+              </a:spcAft>
+              <a:buSzPct val="100000"/>
+              <a:buChar char="•"/>
+            </a:pPr>
+            <a:r>
+              <a:rPr lang="en-US" sz="1700" dirty="0">
+                <a:solidFill>
+                  <a:srgbClr val="E9E2DC"/>
+                </a:solidFill>
+                <a:latin typeface="Calibri" pitchFamily="34" charset="0"/>
+                <a:ea typeface="Calibri" pitchFamily="34" charset="-122"/>
+                <a:cs typeface="Calibri" pitchFamily="34" charset="-120"/>
+              </a:rPr>
+              <a:t>Start capture</a:t>
+            </a:r>
+            <a:endParaRPr lang="en-US" sz="1700" dirty="0"/>
+          </a:p>
+          <a:p>
+            <a:pPr marL="342900" indent="-342900">
+              <a:spcAft>
+                <a:spcPts val="1200"/>
+              </a:spcAft>
+              <a:buSzPct val="100000"/>
+              <a:buChar char="•"/>
+            </a:pPr>
+            <a:r>
+              <a:rPr lang="en-US" sz="1700" dirty="0">
+                <a:solidFill>
+                  <a:srgbClr val="E9E2DC"/>
+                </a:solidFill>
+                <a:latin typeface="Calibri" pitchFamily="34" charset="0"/>
+                <a:ea typeface="Calibri" pitchFamily="34" charset="-122"/>
+                <a:cs typeface="Calibri" pitchFamily="34" charset="-120"/>
+              </a:rPr>
+              <a:t>Switch to the editor  →  press  Cmd+Shift+1</a:t>
+            </a:r>
+            <a:endParaRPr lang="en-US" sz="1700" dirty="0"/>
+          </a:p>
+          <a:p>
+            <a:pPr marL="342900" indent="-342900">
+              <a:spcAft>
+                <a:spcPts val="1200"/>
+              </a:spcAft>
+              <a:buSzPct val="100000"/>
+              <a:buChar char="•"/>
+            </a:pPr>
+            <a:r>
+              <a:rPr lang="en-US" sz="1700" dirty="0">
+                <a:solidFill>
+                  <a:srgbClr val="E9E2DC"/>
+                </a:solidFill>
+                <a:latin typeface="Calibri" pitchFamily="34" charset="0"/>
+                <a:ea typeface="Calibri" pitchFamily="34" charset="-122"/>
+                <a:cs typeface="Calibri" pitchFamily="34" charset="-120"/>
+              </a:rPr>
+              <a:t>Scroll slowly (or not at all for a one-screen file)</a:t>
+            </a:r>
+            <a:endParaRPr lang="en-US" sz="1700" dirty="0"/>
+          </a:p>
+          <a:p>
+            <a:pPr marL="342900" indent="-342900">
+              <a:spcAft>
+                <a:spcPts val="1200"/>
+              </a:spcAft>
+              <a:buSzPct val="100000"/>
+              <a:buChar char="•"/>
+            </a:pPr>
+            <a:r>
+              <a:rPr lang="en-US" sz="1700" dirty="0">
+                <a:solidFill>
+                  <a:srgbClr val="E9E2DC"/>
+                </a:solidFill>
+                <a:latin typeface="Calibri" pitchFamily="34" charset="0"/>
+                <a:ea typeface="Calibri" pitchFamily="34" charset="-122"/>
+                <a:cs typeface="Calibri" pitchFamily="34" charset="-120"/>
+              </a:rPr>
+              <a:t>Walk the report: overview · errors · code · tech review · diagrams</a:t>
+            </a:r>
+            <a:endParaRPr lang="en-US" sz="1700" dirty="0"/>
+          </a:p>
+        </p:txBody>
+      </p:sp>
+      <p:sp>
+        <p:nvSpPr>
+          <p:cNvPr id="6" name="Shape 4"/>
+          <p:cNvSpPr/>
+          <p:nvPr/>
+        </p:nvSpPr>
+        <p:spPr>
+          <a:xfrm>
+            <a:off x="7040880" y="1828800"/>
+            <a:ext cx="4572000" cy="3566160"/>
+          </a:xfrm>
+          <a:prstGeom prst="roundRect">
+            <a:avLst>
+              <a:gd name="adj" fmla="val 2564"/>
+            </a:avLst>
+          </a:prstGeom>
+          <a:solidFill>
+            <a:srgbClr val="3A322C"/>
+          </a:solidFill>
+          <a:ln w="12700">
+            <a:solidFill>
+              <a:srgbClr val="BE6E4A"/>
+            </a:solidFill>
+            <a:prstDash val="dash"/>
+          </a:ln>
+        </p:spPr>
+        <p:txBody>
+          <a:bodyPr/>
+          <a:lstStyle/>
+          <a:p>
+            <a:endParaRPr lang="en-US"/>
+          </a:p>
+        </p:txBody>
+      </p:sp>
+      <p:sp>
+        <p:nvSpPr>
+          <p:cNvPr id="7" name="Text 5"/>
+          <p:cNvSpPr/>
+          <p:nvPr/>
+        </p:nvSpPr>
+        <p:spPr>
+          <a:xfrm>
+            <a:off x="7223760" y="3017520"/>
+            <a:ext cx="4206240" cy="1097280"/>
+          </a:xfrm>
+          <a:prstGeom prst="rect">
+            <a:avLst/>
+          </a:prstGeom>
+          <a:noFill/>
+          <a:ln/>
+        </p:spPr>
+        <p:txBody>
+          <a:bodyPr wrap="square" lIns="0" tIns="0" rIns="0" bIns="0" rtlCol="0" anchor="ctr"/>
+          <a:lstStyle/>
+          <a:p>
+            <a:pPr marL="0" indent="0" algn="ctr">
+              <a:buNone/>
+            </a:pPr>
+            <a:r>
+              <a:rPr lang="en-US" sz="1400" i="1" dirty="0">
+                <a:solidFill>
+                  <a:srgbClr val="B9AEA4"/>
+                </a:solidFill>
+                <a:latin typeface="Calibri" pitchFamily="34" charset="0"/>
+                <a:ea typeface="Calibri" pitchFamily="34" charset="-122"/>
+                <a:cs typeface="Calibri" pitchFamily="34" charset="-120"/>
+              </a:rPr>
+              <a:t>Backup slot</a:t>
+            </a:r>
+            <a:endParaRPr lang="en-US" sz="1400" dirty="0"/>
+          </a:p>
+          <a:p>
+            <a:pPr marL="0" indent="0" algn="ctr">
+              <a:buNone/>
+            </a:pPr>
+            <a:r>
+              <a:rPr lang="en-US" sz="1400" i="1" dirty="0">
+                <a:solidFill>
+                  <a:srgbClr val="B9AEA4"/>
+                </a:solidFill>
+                <a:latin typeface="Calibri" pitchFamily="34" charset="0"/>
+                <a:ea typeface="Calibri" pitchFamily="34" charset="-122"/>
+                <a:cs typeface="Calibri" pitchFamily="34" charset="-120"/>
+              </a:rPr>
+              <a:t>(paste a rehearsal report screenshot here)</a:t>
+            </a:r>
+            <a:endParaRPr lang="en-US" sz="1400" dirty="0"/>
+          </a:p>
+        </p:txBody>
+      </p:sp>
+      <p:sp>
+        <p:nvSpPr>
+          <p:cNvPr id="8" name="Text 6"/>
+          <p:cNvSpPr/>
+          <p:nvPr/>
+        </p:nvSpPr>
+        <p:spPr>
+          <a:xfrm>
+            <a:off x="914400" y="5852160"/>
+            <a:ext cx="10332720" cy="365760"/>
+          </a:xfrm>
+          <a:prstGeom prst="rect">
+            <a:avLst/>
+          </a:prstGeom>
+          <a:noFill/>
+          <a:ln/>
+        </p:spPr>
+        <p:txBody>
+          <a:bodyPr wrap="square" lIns="0" tIns="0" rIns="0" bIns="0" rtlCol="0" anchor="ctr"/>
+          <a:lstStyle/>
+          <a:p>
+            <a:pPr marL="0" indent="0">
+              <a:buNone/>
+            </a:pPr>
+            <a:r>
+              <a:rPr lang="en-US" sz="1300" i="1" dirty="0">
+                <a:solidFill>
+                  <a:srgbClr val="B9AEA4"/>
+                </a:solidFill>
+                <a:latin typeface="Calibri" pitchFamily="34" charset="0"/>
+                <a:ea typeface="Calibri" pitchFamily="34" charset="-122"/>
+                <a:cs typeface="Calibri" pitchFamily="34" charset="-120"/>
+              </a:rPr>
+              <a:t>Line numbers OFF · file fits the screen · keep this backup ready</a:t>
+            </a:r>
+            <a:endParaRPr lang="en-US" sz="1300" dirty="0"/>
+          </a:p>
+        </p:txBody>
+      </p:sp>
+      <p:pic>
+        <p:nvPicPr>
+          <p:cNvPr id="9" name="Picture 8">
+            <a:extLst>
+              <a:ext uri="{FF2B5EF4-FFF2-40B4-BE49-F238E27FC236}">
+                <a16:creationId xmlns:a16="http://schemas.microsoft.com/office/drawing/2014/main" id="{48D8A69B-695C-54D2-E0EC-5672EE906C09}"/>
+              </a:ext>
+            </a:extLst>
+          </p:cNvPr>
+          <p:cNvPicPr>
+            <a:picLocks noChangeAspect="1"/>
+          </p:cNvPicPr>
+          <p:nvPr/>
+        </p:nvPicPr>
+        <p:blipFill>
+          <a:blip r:embed="rId3"/>
+          <a:stretch>
+            <a:fillRect/>
+          </a:stretch>
+        </p:blipFill>
+        <p:spPr>
+          <a:xfrm>
+            <a:off x="6244284" y="982980"/>
+            <a:ext cx="5799432" cy="5257800"/>
           </a:xfrm>
           <a:prstGeom prst="rect">
             <a:avLst/>

</xml_diff>